<commit_message>
Fix missing-glyph/tofu rendering in PDFs: replace U+2192/U+2194 and UML symbols not in Open Sans/Poppins with ASCII equivalents across Weeks 6-16
Co-authored-by: arena-agent <297053741+arena-agent@users.noreply.github.com>
</commit_message>
<xml_diff>
--- a/output/week10/Week10_Presentation_BICT3202_OOAD.pptx
+++ b/output/week10/Week10_Presentation_BICT3202_OOAD.pptx
@@ -7704,7 +7704,7 @@
                 </a:solidFill>
                 <a:latin typeface="Open Sans"/>
               </a:rPr>
-              <a:t>Presentation → Business Logic → Data Access → Database.</a:t>
+              <a:t>Presentation -&gt; Business Logic -&gt; Data Access -&gt; Database.</a:t>
             </a:r>
           </a:p>
         </p:txBody>
@@ -9040,7 +9040,7 @@
                 </a:solidFill>
                 <a:latin typeface="Open Sans"/>
               </a:rPr>
-              <a:t>Progressively add detail: analysis → design → code</a:t>
+              <a:t>Progressively add detail: analysis -&gt; design -&gt; code</a:t>
             </a:r>
           </a:p>
         </p:txBody>
@@ -9225,7 +9225,7 @@
                 </a:solidFill>
                 <a:latin typeface="Open Sans"/>
               </a:rPr>
-              <a:t>Problem → analysis model → design model → implementation → running software.</a:t>
+              <a:t>Problem -&gt; analysis model -&gt; design model -&gt; implementation -&gt; running software.</a:t>
             </a:r>
           </a:p>
         </p:txBody>
@@ -10067,7 +10067,7 @@
                 </a:solidFill>
                 <a:latin typeface="Open Sans"/>
               </a:rPr>
-              <a:t>Requirement → use case → objects → models → sequence → design.</a:t>
+              <a:t>Requirement -&gt; use case -&gt; objects -&gt; models -&gt; sequence -&gt; design.</a:t>
             </a:r>
           </a:p>
         </p:txBody>
@@ -10478,7 +10478,7 @@
                 </a:solidFill>
                 <a:latin typeface="Open Sans"/>
               </a:rPr>
-              <a:t>if the use case actor is Student, the sequence must not show Lecturer → registerCourse().</a:t>
+              <a:t>if the use case actor is Student, the sequence must not show Lecturer -&gt; registerCourse().</a:t>
             </a:r>
           </a:p>
           <a:p>
@@ -10515,7 +10515,7 @@
                 </a:solidFill>
                 <a:latin typeface="Open Sans"/>
               </a:rPr>
-              <a:t>requirement → use case → activity → sequence → class → code → test.</a:t>
+              <a:t>requirement -&gt; use case -&gt; activity -&gt; sequence -&gt; class -&gt; code -&gt; test.</a:t>
             </a:r>
           </a:p>
         </p:txBody>
@@ -11107,7 +11107,7 @@
                 </a:solidFill>
                 <a:latin typeface="Open Sans"/>
               </a:rPr>
-              <a:t>can both implement the same interface → lower coupling.</a:t>
+              <a:t>can both implement the same interface -&gt; lower coupling.</a:t>
             </a:r>
           </a:p>
         </p:txBody>
@@ -11994,7 +11994,7 @@
                 </a:solidFill>
                 <a:latin typeface="Open Sans"/>
               </a:rPr>
-              <a:t>Requirements → models → design → code</a:t>
+              <a:t>Requirements -&gt; models -&gt; design -&gt; code</a:t>
             </a:r>
           </a:p>
         </p:txBody>

</xml_diff>